<commit_message>
fix: clarify lesson 10 MCP deck contracts
</commit_message>
<xml_diff>
--- a/decks/10-financial-mcp.pptx
+++ b/decks/10-financial-mcp.pptx
@@ -2,21 +2,21 @@
 <file path=ppt/presentation.xml><?xml version="1.0" encoding="utf-8"?>
 <p:presentation xmlns:p="http://schemas.openxmlformats.org/presentationml/2006/main">
   <p:sldMasterIdLst>
-    <p:sldMasterId xmlns:r="http://schemas.openxmlformats.org/officeDocument/2006/relationships" id="2147483648" r:id="Rf1cec187b0974e44"/>
+    <p:sldMasterId xmlns:r="http://schemas.openxmlformats.org/officeDocument/2006/relationships" id="2147483648" r:id="R9b019339bfef4374"/>
   </p:sldMasterIdLst>
   <p:notesMasterIdLst>
-    <p:notesMasterId xmlns:r="http://schemas.openxmlformats.org/officeDocument/2006/relationships" r:id="Rf07b1a3f617d48e2"/>
+    <p:notesMasterId xmlns:r="http://schemas.openxmlformats.org/officeDocument/2006/relationships" r:id="R1a72bae5d9244703"/>
   </p:notesMasterIdLst>
   <p:sldIdLst>
-    <p:sldId xmlns:r="http://schemas.openxmlformats.org/officeDocument/2006/relationships" id="256" r:id="R87f43d056bbd4979"/>
-    <p:sldId xmlns:r="http://schemas.openxmlformats.org/officeDocument/2006/relationships" id="257" r:id="R4ca5d7f16b4e458f"/>
-    <p:sldId xmlns:r="http://schemas.openxmlformats.org/officeDocument/2006/relationships" id="258" r:id="Redbe858add714ed9"/>
-    <p:sldId xmlns:r="http://schemas.openxmlformats.org/officeDocument/2006/relationships" id="259" r:id="R46ca3e9e3b5b42a2"/>
-    <p:sldId xmlns:r="http://schemas.openxmlformats.org/officeDocument/2006/relationships" id="260" r:id="Rd105bd7d2b3746a2"/>
-    <p:sldId xmlns:r="http://schemas.openxmlformats.org/officeDocument/2006/relationships" id="261" r:id="R50e217fda75e49e2"/>
-    <p:sldId xmlns:r="http://schemas.openxmlformats.org/officeDocument/2006/relationships" id="262" r:id="Rb2ba63736d6c401c"/>
-    <p:sldId xmlns:r="http://schemas.openxmlformats.org/officeDocument/2006/relationships" id="263" r:id="Re44ce5ae02bf4926"/>
-    <p:sldId xmlns:r="http://schemas.openxmlformats.org/officeDocument/2006/relationships" id="264" r:id="Rc7df9206b87a4469"/>
+    <p:sldId xmlns:r="http://schemas.openxmlformats.org/officeDocument/2006/relationships" id="256" r:id="R3623f8762c0041c3"/>
+    <p:sldId xmlns:r="http://schemas.openxmlformats.org/officeDocument/2006/relationships" id="257" r:id="Rad5febee051240ff"/>
+    <p:sldId xmlns:r="http://schemas.openxmlformats.org/officeDocument/2006/relationships" id="258" r:id="R7d9997dcff7749b9"/>
+    <p:sldId xmlns:r="http://schemas.openxmlformats.org/officeDocument/2006/relationships" id="259" r:id="Reb19b30c03c14543"/>
+    <p:sldId xmlns:r="http://schemas.openxmlformats.org/officeDocument/2006/relationships" id="260" r:id="R50fd9e211df84aa7"/>
+    <p:sldId xmlns:r="http://schemas.openxmlformats.org/officeDocument/2006/relationships" id="261" r:id="Rd0e253d17a524620"/>
+    <p:sldId xmlns:r="http://schemas.openxmlformats.org/officeDocument/2006/relationships" id="262" r:id="Rfff2d324a72d449e"/>
+    <p:sldId xmlns:r="http://schemas.openxmlformats.org/officeDocument/2006/relationships" id="263" r:id="Rec8f73c88f1140c7"/>
+    <p:sldId xmlns:r="http://schemas.openxmlformats.org/officeDocument/2006/relationships" id="264" r:id="Rcf5c0bbebbcc4a35"/>
   </p:sldIdLst>
   <p:sldSz cx="15240000" cy="8572500"/>
   <p:notesSz cx="6858000" cy="9144000"/>
@@ -1213,7 +1213,7 @@
   </p:cSld>
   <p:clrMap bg1="lt1" tx1="dk1" bg2="lt2" tx2="dk2" accent1="accent1" accent2="accent2" accent3="accent3" accent4="accent4" accent5="accent5" accent6="accent6" hlink="hlink" folHlink="folHlink"/>
   <p:sldLayoutIdLst>
-    <p:sldLayoutId xmlns:r="http://schemas.openxmlformats.org/officeDocument/2006/relationships" id="2147483649" r:id="R2c80a9b087e74b4c"/>
+    <p:sldLayoutId xmlns:r="http://schemas.openxmlformats.org/officeDocument/2006/relationships" id="2147483649" r:id="R8d5af308b7a3451d"/>
   </p:sldLayoutIdLst>
   <p:txStyles>
     <p:titleStyle>
@@ -5807,7 +5807,7 @@
                 <a:ea typeface="Calibri"/>
                 <a:cs typeface="Calibri"/>
               </a:rPr>
-              <a:t>application</a:t>
+              <a:t>application controls</a:t>
             </a:r>
           </a:p>
         </p:txBody>
@@ -6098,7 +6098,7 @@
                 <a:ea typeface="Calibri"/>
                 <a:cs typeface="Calibri"/>
               </a:rPr>
-              <a:t>host</a:t>
+              <a:t>context</a:t>
             </a:r>
           </a:p>
         </p:txBody>
@@ -6160,7 +6160,7 @@
                 <a:ea typeface="Calibri"/>
                 <a:cs typeface="Calibri"/>
               </a:rPr>
-              <a:t>control</a:t>
+              <a:t>resource</a:t>
             </a:r>
           </a:p>
         </p:txBody>
@@ -7940,7 +7940,7 @@
                 <a:ea typeface="Calibri"/>
                 <a:cs typeface="Calibri"/>
               </a:rPr>
-              <a:t>TOOLS</a:t>
+              <a:t>READ ONLY</a:t>
             </a:r>
           </a:p>
         </p:txBody>
@@ -8002,7 +8002,7 @@
                 <a:ea typeface="Calibri"/>
                 <a:cs typeface="Calibri"/>
               </a:rPr>
-              <a:t>get_company_metric</a:t>
+              <a:t>PROMPT</a:t>
             </a:r>
           </a:p>
         </p:txBody>
@@ -8099,7 +8099,7 @@
                 <a:ea typeface="Calibri"/>
                 <a:cs typeface="Calibri"/>
               </a:rPr>
-              <a:t>metric lookup</a:t>
+              <a:t>compare_companies</a:t>
             </a:r>
           </a:p>
         </p:txBody>
@@ -8196,7 +8196,7 @@
                 <a:ea typeface="Calibri"/>
                 <a:cs typeface="Calibri"/>
               </a:rPr>
-              <a:t>document search</a:t>
+              <a:t>user controlled</a:t>
             </a:r>
           </a:p>
         </p:txBody>
@@ -8293,7 +8293,7 @@
                 <a:ea typeface="Calibri"/>
                 <a:cs typeface="Calibri"/>
               </a:rPr>
-              <a:t>host approved</a:t>
+              <a:t>1</a:t>
             </a:r>
           </a:p>
         </p:txBody>
@@ -8355,7 +8355,7 @@
                 <a:ea typeface="Calibri"/>
                 <a:cs typeface="Calibri"/>
               </a:rPr>
-              <a:t>2</a:t>
+              <a:t>USER</a:t>
             </a:r>
           </a:p>
         </p:txBody>
@@ -8417,7 +8417,7 @@
                 <a:ea typeface="Calibri"/>
                 <a:cs typeface="Calibri"/>
               </a:rPr>
-              <a:t>PROMPT</a:t>
+              <a:t>TOOLS</a:t>
             </a:r>
           </a:p>
         </p:txBody>
@@ -8514,7 +8514,7 @@
                 <a:ea typeface="Calibri"/>
                 <a:cs typeface="Calibri"/>
               </a:rPr>
-              <a:t>compare_companies</a:t>
+              <a:t>get_company_metric</a:t>
             </a:r>
           </a:p>
         </p:txBody>
@@ -8611,7 +8611,7 @@
                 <a:ea typeface="Calibri"/>
                 <a:cs typeface="Calibri"/>
               </a:rPr>
-              <a:t>user controlled</a:t>
+              <a:t>search_financial_documents</a:t>
             </a:r>
           </a:p>
         </p:txBody>
@@ -8673,7 +8673,7 @@
                 <a:ea typeface="Calibri"/>
                 <a:cs typeface="Calibri"/>
               </a:rPr>
-              <a:t>1</a:t>
+              <a:t>2</a:t>
             </a:r>
           </a:p>
         </p:txBody>
@@ -11450,7 +11450,8 @@
                 <a:ea typeface="Calibri"/>
                 <a:cs typeface="Calibri"/>
               </a:rPr>
-              <a:t>opens stdio</a:t>
+              <a:t>opens stdio
+requests catalog</a:t>
             </a:r>
           </a:p>
         </p:txBody>
@@ -11671,7 +11672,7 @@
                 <a:ea typeface="Calibri"/>
                 <a:cs typeface="Calibri"/>
               </a:rPr>
-              <a:t>lists capabilities</a:t>
+              <a:t>returns catalog</a:t>
             </a:r>
           </a:p>
         </p:txBody>
@@ -12967,7 +12968,7 @@
                 <a:ea typeface="Calibri"/>
                 <a:cs typeface="Calibri"/>
               </a:rPr>
-              <a:t>known tool name</a:t>
+              <a:t>known + allowed</a:t>
             </a:r>
           </a:p>
         </p:txBody>
@@ -13064,7 +13065,7 @@
                 <a:ea typeface="Calibri"/>
                 <a:cs typeface="Calibri"/>
               </a:rPr>
-              <a:t>host policy</a:t>
+              <a:t>PERMIT</a:t>
             </a:r>
           </a:p>
         </p:txBody>
@@ -13161,7 +13162,7 @@
                 <a:ea typeface="Calibri"/>
                 <a:cs typeface="Calibri"/>
               </a:rPr>
-              <a:t>unknown tool</a:t>
+              <a:t>unknown</a:t>
             </a:r>
           </a:p>
         </p:txBody>
@@ -13320,7 +13321,7 @@
                 <a:ea typeface="Calibri"/>
                 <a:cs typeface="Calibri"/>
               </a:rPr>
-              <a:t>PERMIT</a:t>
+              <a:t>ALLOWLIST</a:t>
             </a:r>
           </a:p>
         </p:txBody>
@@ -13479,7 +13480,7 @@
                 <a:ea typeface="Calibri"/>
                 <a:cs typeface="Calibri"/>
               </a:rPr>
-              <a:t>safe arguments</a:t>
+              <a:t>valid args</a:t>
             </a:r>
           </a:p>
         </p:txBody>
@@ -13576,7 +13577,7 @@
                 <a:ea typeface="Calibri"/>
                 <a:cs typeface="Calibri"/>
               </a:rPr>
-              <a:t>typed input</a:t>
+              <a:t>RUN</a:t>
             </a:r>
           </a:p>
         </p:txBody>
@@ -13673,7 +13674,7 @@
                 <a:ea typeface="Calibri"/>
                 <a:cs typeface="Calibri"/>
               </a:rPr>
-              <a:t>bad request</a:t>
+              <a:t>invalid args</a:t>
             </a:r>
           </a:p>
         </p:txBody>

</xml_diff>